<commit_message>
docs: fix RegLens deck layout (slides 8, 13, 19)
- Slide 13: recrop screenshot to drop the dead left margin so the image
  fills the full 9.0in width at the same aspect ratio as the frame.
- Slide 8: add a 0.15in gap between the "abstained" badge card and the
  "Why this matters" box (they were touching).
- Slide 19: widen the KPI table (colW 1.45/1.15/1.0) and shorten the
  "How measured" cells so none wrap past one line.
</commit_message>
<xml_diff>
--- a/docs/pitch/reglens-architecture-deck.pptx
+++ b/docs/pitch/reglens-architecture-deck.pptx
@@ -7025,8 +7025,8 @@
         </p:blipFill>
         <p:spPr>
           <a:xfrm>
-            <a:off x="1451564" y="1143000"/>
-            <a:ext cx="6240872" cy="3246120"/>
+            <a:off x="457366" y="1143000"/>
+            <a:ext cx="8229268" cy="3246120"/>
           </a:xfrm>
           <a:prstGeom prst="rect">
             <a:avLst/>
@@ -11665,9 +11665,9 @@
             <a:tbl>
               <a:tblPr/>
               <a:tblGrid>
-                <a:gridCol w="1508760"/>
+                <a:gridCol w="1325880"/>
                 <a:gridCol w="1051560"/>
-                <a:gridCol w="731520"/>
+                <a:gridCol w="914400"/>
               </a:tblGrid>
               <a:tr h="0">
                 <a:tc>
@@ -12023,7 +12023,7 @@
                           <a:ea typeface="Calibri" pitchFamily="34" charset="-122"/>
                           <a:cs typeface="Calibri" pitchFamily="34" charset="-120"/>
                         </a:rPr>
-                        <a:t>default pytest marker set, this run</a:t>
+                        <a:t>pytest, this run</a:t>
                       </a:r>
                       <a:endParaRPr lang="en-US" sz="750" dirty="0">
                         <a:latin typeface="Calibri" charset="0"/>
@@ -12220,7 +12220,7 @@
                           <a:ea typeface="Calibri" pitchFamily="34" charset="-122"/>
                           <a:cs typeface="Calibri" pitchFamily="34" charset="-120"/>
                         </a:rPr>
-                        <a:t>make eval, this run</a:t>
+                        <a:t>make eval</a:t>
                       </a:r>
                       <a:endParaRPr lang="en-US" sz="750" dirty="0">
                         <a:latin typeface="Calibri" charset="0"/>
@@ -12417,7 +12417,7 @@
                           <a:ea typeface="Calibri" pitchFamily="34" charset="-122"/>
                           <a:cs typeface="Calibri" pitchFamily="34" charset="-120"/>
                         </a:rPr>
-                        <a:t>make eval, this run</a:t>
+                        <a:t>make eval</a:t>
                       </a:r>
                       <a:endParaRPr lang="en-US" sz="750" dirty="0">
                         <a:latin typeface="Calibri" charset="0"/>
@@ -12614,7 +12614,7 @@
                           <a:ea typeface="Calibri" pitchFamily="34" charset="-122"/>
                           <a:cs typeface="Calibri" pitchFamily="34" charset="-120"/>
                         </a:rPr>
-                        <a:t>headline.json bars</a:t>
+                        <a:t>headline.json</a:t>
                       </a:r>
                       <a:endParaRPr lang="en-US" sz="750" dirty="0">
                         <a:latin typeface="Calibri" charset="0"/>
@@ -12811,7 +12811,7 @@
                           <a:ea typeface="Calibri" pitchFamily="34" charset="-122"/>
                           <a:cs typeface="Calibri" pitchFamily="34" charset="-120"/>
                         </a:rPr>
-                        <a:t>repo costing model, observed</a:t>
+                        <a:t>costing model</a:t>
                       </a:r>
                       <a:endParaRPr lang="en-US" sz="750" dirty="0">
                         <a:latin typeface="Calibri" charset="0"/>
@@ -13008,7 +13008,7 @@
                           <a:ea typeface="Calibri" pitchFamily="34" charset="-122"/>
                           <a:cs typeface="Calibri" pitchFamily="34" charset="-120"/>
                         </a:rPr>
-                        <a:t>make eval, this run</a:t>
+                        <a:t>make eval</a:t>
                       </a:r>
                       <a:endParaRPr lang="en-US" sz="750" dirty="0">
                         <a:latin typeface="Calibri" charset="0"/>
@@ -13205,7 +13205,7 @@
                           <a:ea typeface="Calibri" pitchFamily="34" charset="-122"/>
                           <a:cs typeface="Calibri" pitchFamily="34" charset="-120"/>
                         </a:rPr>
-                        <a:t>needs a key / a model download</a:t>
+                        <a:t>needs key/model</a:t>
                       </a:r>
                       <a:endParaRPr lang="en-US" sz="750" dirty="0">
                         <a:latin typeface="Calibri" charset="0"/>
@@ -28618,11 +28618,11 @@
         <p:spPr>
           <a:xfrm>
             <a:off x="4937760" y="1188720"/>
-            <a:ext cx="3749040" cy="566928"/>
+            <a:ext cx="3749040" cy="530352"/>
           </a:xfrm>
           <a:prstGeom prst="roundRect">
             <a:avLst>
-              <a:gd name="adj" fmla="val 9677"/>
+              <a:gd name="adj" fmla="val 10345"/>
             </a:avLst>
           </a:prstGeom>
           <a:solidFill>
@@ -28644,7 +28644,7 @@
         </p:nvSpPr>
         <p:spPr>
           <a:xfrm>
-            <a:off x="5074920" y="1234440"/>
+            <a:off x="5074920" y="1225296"/>
             <a:ext cx="1371600" cy="457200"/>
           </a:xfrm>
           <a:prstGeom prst="rect">
@@ -28683,7 +28683,7 @@
         </p:nvSpPr>
         <p:spPr>
           <a:xfrm>
-            <a:off x="6400800" y="1234440"/>
+            <a:off x="6400800" y="1225296"/>
             <a:ext cx="2194560" cy="457200"/>
           </a:xfrm>
           <a:prstGeom prst="rect">
@@ -28722,12 +28722,12 @@
         </p:nvSpPr>
         <p:spPr>
           <a:xfrm>
-            <a:off x="4937760" y="1874520"/>
-            <a:ext cx="3749040" cy="566928"/>
+            <a:off x="4937760" y="1828800"/>
+            <a:ext cx="3749040" cy="530352"/>
           </a:xfrm>
           <a:prstGeom prst="roundRect">
             <a:avLst>
-              <a:gd name="adj" fmla="val 9677"/>
+              <a:gd name="adj" fmla="val 10345"/>
             </a:avLst>
           </a:prstGeom>
           <a:solidFill>
@@ -28749,7 +28749,7 @@
         </p:nvSpPr>
         <p:spPr>
           <a:xfrm>
-            <a:off x="5074920" y="1920240"/>
+            <a:off x="5074920" y="1865376"/>
             <a:ext cx="1371600" cy="457200"/>
           </a:xfrm>
           <a:prstGeom prst="rect">
@@ -28788,7 +28788,7 @@
         </p:nvSpPr>
         <p:spPr>
           <a:xfrm>
-            <a:off x="6400800" y="1920240"/>
+            <a:off x="6400800" y="1865376"/>
             <a:ext cx="2194560" cy="457200"/>
           </a:xfrm>
           <a:prstGeom prst="rect">
@@ -28827,12 +28827,12 @@
         </p:nvSpPr>
         <p:spPr>
           <a:xfrm>
-            <a:off x="4937760" y="2560320"/>
-            <a:ext cx="3749040" cy="566928"/>
+            <a:off x="4937760" y="2468880"/>
+            <a:ext cx="3749040" cy="530352"/>
           </a:xfrm>
           <a:prstGeom prst="roundRect">
             <a:avLst>
-              <a:gd name="adj" fmla="val 9677"/>
+              <a:gd name="adj" fmla="val 10345"/>
             </a:avLst>
           </a:prstGeom>
           <a:solidFill>
@@ -28854,7 +28854,7 @@
         </p:nvSpPr>
         <p:spPr>
           <a:xfrm>
-            <a:off x="5074920" y="2606040"/>
+            <a:off x="5074920" y="2505456"/>
             <a:ext cx="1371600" cy="457200"/>
           </a:xfrm>
           <a:prstGeom prst="rect">
@@ -28893,7 +28893,7 @@
         </p:nvSpPr>
         <p:spPr>
           <a:xfrm>
-            <a:off x="6400800" y="2606040"/>
+            <a:off x="6400800" y="2505456"/>
             <a:ext cx="2194560" cy="457200"/>
           </a:xfrm>
           <a:prstGeom prst="rect">
@@ -28932,12 +28932,12 @@
         </p:nvSpPr>
         <p:spPr>
           <a:xfrm>
-            <a:off x="4937760" y="3246120"/>
-            <a:ext cx="3749040" cy="566928"/>
+            <a:off x="4937760" y="3108960"/>
+            <a:ext cx="3749040" cy="530352"/>
           </a:xfrm>
           <a:prstGeom prst="roundRect">
             <a:avLst>
-              <a:gd name="adj" fmla="val 9677"/>
+              <a:gd name="adj" fmla="val 10345"/>
             </a:avLst>
           </a:prstGeom>
           <a:solidFill>
@@ -28959,7 +28959,7 @@
         </p:nvSpPr>
         <p:spPr>
           <a:xfrm>
-            <a:off x="5074920" y="3291840"/>
+            <a:off x="5074920" y="3145536"/>
             <a:ext cx="1371600" cy="457200"/>
           </a:xfrm>
           <a:prstGeom prst="rect">
@@ -28998,7 +28998,7 @@
         </p:nvSpPr>
         <p:spPr>
           <a:xfrm>
-            <a:off x="6400800" y="3291840"/>
+            <a:off x="6400800" y="3145536"/>
             <a:ext cx="2194560" cy="457200"/>
           </a:xfrm>
           <a:prstGeom prst="rect">
@@ -29037,12 +29037,12 @@
         </p:nvSpPr>
         <p:spPr>
           <a:xfrm>
-            <a:off x="4937760" y="3840480"/>
-            <a:ext cx="3749040" cy="594360"/>
+            <a:off x="4937760" y="3776472"/>
+            <a:ext cx="3749040" cy="658368"/>
           </a:xfrm>
           <a:prstGeom prst="roundRect">
             <a:avLst>
-              <a:gd name="adj" fmla="val 9231"/>
+              <a:gd name="adj" fmla="val 8333"/>
             </a:avLst>
           </a:prstGeom>
           <a:solidFill>
@@ -29064,7 +29064,7 @@
         </p:nvSpPr>
         <p:spPr>
           <a:xfrm>
-            <a:off x="5029200" y="3895344"/>
+            <a:off x="5029200" y="3831336"/>
             <a:ext cx="3566160" cy="256032"/>
           </a:xfrm>
           <a:prstGeom prst="rect">
@@ -29103,8 +29103,8 @@
         </p:nvSpPr>
         <p:spPr>
           <a:xfrm>
-            <a:off x="5029200" y="4151376"/>
-            <a:ext cx="3566160" cy="228600"/>
+            <a:off x="5029200" y="4087368"/>
+            <a:ext cx="3566160" cy="292608"/>
           </a:xfrm>
           <a:prstGeom prst="rect">
             <a:avLst/>

</xml_diff>